<commit_message>
이름 변경 glc2d -> glc, glc2d_ -> g2
</commit_message>
<xml_diff>
--- a/doc/glc_2d_lib.pptx
+++ b/doc/glc_2d_lib.pptx
@@ -8899,7 +8899,7 @@
               <a:rPr lang="en-US" altLang="ko-KR" dirty="0">
                 <a:latin typeface="+mn-ea"/>
               </a:rPr>
-              <a:t>glc2d_CreateWin</a:t>
+              <a:t>g2_CreateWin</a:t>
             </a:r>
           </a:p>
           <a:p>
@@ -8908,7 +8908,7 @@
               <a:rPr lang="en-US" altLang="ko-KR" dirty="0">
                 <a:latin typeface="+mn-ea"/>
               </a:rPr>
-              <a:t>glc2d_DestroyWin</a:t>
+              <a:t>g2_DestroyWin</a:t>
             </a:r>
           </a:p>
           <a:p>
@@ -8949,7 +8949,7 @@
               <a:rPr lang="en-US" altLang="ko-KR" dirty="0">
                 <a:latin typeface="+mn-ea"/>
               </a:rPr>
-              <a:t>glc2d_Run</a:t>
+              <a:t>g2_Run</a:t>
             </a:r>
           </a:p>
           <a:p>
@@ -9753,7 +9753,7 @@
               <a:rPr lang="en-US" altLang="ko-KR" dirty="0">
                 <a:latin typeface="+mn-ea"/>
               </a:rPr>
-              <a:t>glc2d_SetRender</a:t>
+              <a:t>g2_SetRender</a:t>
             </a:r>
           </a:p>
           <a:p>
@@ -9830,7 +9830,7 @@
               <a:rPr lang="en-US" altLang="ko-KR" dirty="0">
                 <a:latin typeface="+mn-ea"/>
               </a:rPr>
-              <a:t>glc2d_SetFrameMove</a:t>
+              <a:t>g2_SetFrameMove</a:t>
             </a:r>
           </a:p>
           <a:p>
@@ -10014,7 +10014,7 @@
               <a:rPr lang="en-US" altLang="ko-KR" dirty="0">
                 <a:latin typeface="+mn-ea"/>
               </a:rPr>
-              <a:t>glc2d_TextureLoad</a:t>
+              <a:t>g2_TextureLoad</a:t>
             </a:r>
           </a:p>
           <a:p>
@@ -10109,7 +10109,7 @@
               <a:rPr lang="en-US" altLang="ko-KR" dirty="0">
                 <a:latin typeface="+mn-ea"/>
               </a:rPr>
-              <a:t>glc2d_TextureRelease</a:t>
+              <a:t>g2_TextureRelease</a:t>
             </a:r>
           </a:p>
           <a:p>
@@ -10164,7 +10164,7 @@
               <a:rPr lang="en-US" altLang="ko-KR" dirty="0">
                 <a:latin typeface="+mn-ea"/>
               </a:rPr>
-              <a:t>glc2d_TextureWidth</a:t>
+              <a:t>g2_TextureWidth</a:t>
             </a:r>
           </a:p>
           <a:p>
@@ -10203,7 +10203,7 @@
               <a:rPr lang="en-US" altLang="ko-KR" dirty="0">
                 <a:latin typeface="+mn-ea"/>
               </a:rPr>
-              <a:t>glc2d_TextureHeight</a:t>
+              <a:t>g2_TextureHeight</a:t>
             </a:r>
           </a:p>
         </p:txBody>
@@ -10331,7 +10331,7 @@
               <a:rPr lang="en-US" altLang="ko-KR" dirty="0">
                 <a:latin typeface="+mn-ea"/>
               </a:rPr>
-              <a:t>glc2d_Draw2D</a:t>
+              <a:t>g2_Draw2D</a:t>
             </a:r>
           </a:p>
           <a:p>
@@ -10701,7 +10701,7 @@
               <a:rPr lang="en-US" altLang="ko-KR" dirty="0">
                 <a:latin typeface="+mn-ea"/>
               </a:rPr>
-              <a:t>glc2d_DrawAlphaOption</a:t>
+              <a:t>g2_DrawAlphaOption</a:t>
             </a:r>
           </a:p>
         </p:txBody>
@@ -11019,7 +11019,7 @@
               <a:rPr lang="en-US" altLang="ko-KR" dirty="0">
                 <a:latin typeface="+mn-ea"/>
               </a:rPr>
-              <a:t>X: glc2d_GetMouseX</a:t>
+              <a:t>X: g2_GetMouseX</a:t>
             </a:r>
           </a:p>
           <a:p>
@@ -11028,7 +11028,7 @@
               <a:rPr lang="en-US" altLang="ko-KR" dirty="0">
                 <a:latin typeface="+mn-ea"/>
               </a:rPr>
-              <a:t>Y: glc2d_GetMouseY</a:t>
+              <a:t>Y: g2_GetMouseY</a:t>
             </a:r>
           </a:p>
           <a:p>
@@ -11037,7 +11037,7 @@
               <a:rPr lang="en-US" altLang="ko-KR" dirty="0">
                 <a:latin typeface="+mn-ea"/>
               </a:rPr>
-              <a:t>Z(Wheel): glc2d_GetMouseZ</a:t>
+              <a:t>Z(Wheel): g2_GetMouseZ</a:t>
             </a:r>
           </a:p>
           <a:p>
@@ -11063,7 +11063,7 @@
               <a:rPr lang="en-US" altLang="ko-KR" dirty="0">
                 <a:latin typeface="+mn-ea"/>
               </a:rPr>
-              <a:t>glc2d_GetMouseEvent</a:t>
+              <a:t>g2_GetMouseEvent</a:t>
             </a:r>
           </a:p>
           <a:p>
@@ -11288,7 +11288,7 @@
               <a:rPr lang="en-US" altLang="ko-KR" dirty="0">
                 <a:latin typeface="+mn-ea"/>
               </a:rPr>
-              <a:t>glc2d_GetKeyboard</a:t>
+              <a:t>g2_GetKeyboard</a:t>
             </a:r>
           </a:p>
           <a:p>
@@ -11613,7 +11613,7 @@
               <a:rPr lang="en-US" altLang="ko-KR" dirty="0">
                 <a:latin typeface="+mn-ea"/>
               </a:rPr>
-              <a:t>glc2d_TimeGetTime</a:t>
+              <a:t>g2_TimeGetTime</a:t>
             </a:r>
           </a:p>
           <a:p>
@@ -11868,7 +11868,7 @@
               <a:rPr lang="en-US" altLang="ko-KR" dirty="0">
                 <a:latin typeface="+mn-ea"/>
               </a:rPr>
-              <a:t>glc2d_FontCreate</a:t>
+              <a:t>g2_FontCreate</a:t>
             </a:r>
           </a:p>
           <a:p>
@@ -11907,7 +11907,7 @@
               <a:rPr lang="en-US" altLang="ko-KR" dirty="0">
                 <a:latin typeface="+mn-ea"/>
               </a:rPr>
-              <a:t>glc2d_FontDrawText</a:t>
+              <a:t>g2_FontDrawText</a:t>
             </a:r>
           </a:p>
           <a:p>
@@ -12237,7 +12237,7 @@
               <a:rPr lang="en-US" altLang="ko-KR" dirty="0">
                 <a:latin typeface="+mn-ea"/>
               </a:rPr>
-              <a:t>: glc2d_SoundLoad /Release</a:t>
+              <a:t>: g2_SoundLoad /Release</a:t>
             </a:r>
           </a:p>
           <a:p>
@@ -12275,7 +12275,7 @@
               <a:rPr lang="en-US" altLang="ko-KR" dirty="0">
                 <a:latin typeface="+mn-ea"/>
               </a:rPr>
-              <a:t>: glc2d_SoundPlay</a:t>
+              <a:t>: g2_SoundPlay</a:t>
             </a:r>
           </a:p>
           <a:p>
@@ -12294,7 +12294,7 @@
               <a:rPr lang="en-US" altLang="ko-KR" dirty="0">
                 <a:latin typeface="+mn-ea"/>
               </a:rPr>
-              <a:t>: glc2d_SoundStop</a:t>
+              <a:t>: g2_SoundStop</a:t>
             </a:r>
           </a:p>
           <a:p>
@@ -12308,7 +12308,7 @@
               <a:rPr lang="en-US" altLang="ko-KR" dirty="0">
                 <a:latin typeface="+mn-ea"/>
               </a:rPr>
-              <a:t>Reset: glc2d_SoundReset</a:t>
+              <a:t>Reset: g2_SoundReset</a:t>
             </a:r>
           </a:p>
           <a:p>
@@ -12352,7 +12352,7 @@
               <a:rPr lang="en-US" altLang="ko-KR" dirty="0">
                 <a:latin typeface="+mn-ea"/>
               </a:rPr>
-              <a:t>: glc2d_SoundIsPlaying</a:t>
+              <a:t>: g2_SoundIsPlaying</a:t>
             </a:r>
           </a:p>
         </p:txBody>
@@ -13433,7 +13433,7 @@
               <a:rPr lang="en-US" altLang="ko-KR" sz="2400" dirty="0">
                 <a:latin typeface="+mn-ea"/>
               </a:rPr>
-              <a:t>: glc2d_GetHwnd</a:t>
+              <a:t>: g2_GetHwnd</a:t>
             </a:r>
           </a:p>
           <a:p>
@@ -13464,13 +13464,13 @@
               <a:rPr lang="en-US" altLang="ko-KR" sz="2400" dirty="0">
                 <a:latin typeface="+mn-ea"/>
               </a:rPr>
-              <a:t>: </a:t>
-            </a:r>
-            <a:r>
-              <a:rPr lang="ko-KR" altLang="ko-KR" sz="2400" dirty="0">
-                <a:latin typeface="+mn-ea"/>
-              </a:rPr>
-              <a:t>glc2d_GetScn</a:t>
+              <a:t>: g2_</a:t>
+            </a:r>
+            <a:r>
+              <a:rPr lang="ko-KR" altLang="ko-KR" sz="2400" dirty="0" err="1">
+                <a:latin typeface="+mn-ea"/>
+              </a:rPr>
+              <a:t>GetScn</a:t>
             </a:r>
             <a:r>
               <a:rPr lang="en-US" altLang="ko-KR" sz="2400" dirty="0">
@@ -13519,7 +13519,7 @@
               <a:rPr lang="en-US" altLang="ko-KR" sz="2400" dirty="0">
                 <a:latin typeface="+mn-ea"/>
               </a:rPr>
-              <a:t>: glc2d_{</a:t>
+              <a:t>: g2_{</a:t>
             </a:r>
             <a:r>
               <a:rPr lang="en-US" altLang="ko-KR" sz="2400" dirty="0" err="1">
@@ -13565,7 +13565,7 @@
               <a:rPr lang="en-US" altLang="ko-KR" sz="2400" dirty="0">
                 <a:latin typeface="+mn-ea"/>
               </a:rPr>
-              <a:t>: glc2d_SetWindowIcon</a:t>
+              <a:t>: g2_SetWindowIcon</a:t>
             </a:r>
           </a:p>
           <a:p>
@@ -13602,7 +13602,7 @@
               <a:rPr lang="en-US" altLang="ko-KR" sz="2400" dirty="0">
                 <a:latin typeface="+mn-ea"/>
               </a:rPr>
-              <a:t>: glc2d_{</a:t>
+              <a:t>: g2_{</a:t>
             </a:r>
             <a:r>
               <a:rPr lang="en-US" altLang="ko-KR" sz="2400" dirty="0" err="1">
@@ -13642,13 +13642,13 @@
               <a:rPr lang="en-US" altLang="ko-KR" sz="2400" dirty="0">
                 <a:latin typeface="+mn-ea"/>
               </a:rPr>
-              <a:t>: </a:t>
-            </a:r>
-            <a:r>
-              <a:rPr lang="ko-KR" altLang="ko-KR" sz="2400" dirty="0">
-                <a:latin typeface="+mn-ea"/>
-              </a:rPr>
-              <a:t>glc2d_SetStateShow</a:t>
+              <a:t>: g2_</a:t>
+            </a:r>
+            <a:r>
+              <a:rPr lang="ko-KR" altLang="ko-KR" sz="2400" dirty="0" err="1">
+                <a:latin typeface="+mn-ea"/>
+              </a:rPr>
+              <a:t>SetStateShow</a:t>
             </a:r>
             <a:endParaRPr lang="en-US" altLang="ko-KR" sz="2400" dirty="0">
               <a:latin typeface="+mn-ea"/>
@@ -13670,7 +13670,7 @@
               <a:rPr lang="en-US" altLang="ko-KR" sz="2400" dirty="0">
                 <a:latin typeface="+mn-ea"/>
               </a:rPr>
-              <a:t>: glc2d_SetCursorShow</a:t>
+              <a:t>: g2_SetCursorShow</a:t>
             </a:r>
           </a:p>
         </p:txBody>

</xml_diff>